<commit_message>
Implement enterprise HR, Manager, and Employee modules with direct HR landing and updated presentation
</commit_message>
<xml_diff>
--- a/HR_Hub_Project_Presentation.pptx
+++ b/HR_Hub_Project_Presentation.pptx
@@ -3364,7 +3364,7 @@
               <a:spcAft>
                 <a:spcPts val="200"/>
               </a:spcAft>
-              <a:defRPr sz="1350" b="1">
+              <a:defRPr sz="1300" b="1">
                 <a:solidFill>
                   <a:srgbClr val="0F172A"/>
                 </a:solidFill>
@@ -3379,7 +3379,7 @@
               <a:spcAft>
                 <a:spcPts val="800"/>
               </a:spcAft>
-              <a:defRPr sz="1000">
+              <a:defRPr sz="950">
                 <a:solidFill>
                   <a:srgbClr val="64748B"/>
                 </a:solidFill>
@@ -3396,20 +3396,20 @@
               </a:spcAft>
             </a:pPr>
             <a:r>
-              <a:rPr b="1" sz="1050">
+              <a:rPr b="1" sz="1000">
                 <a:solidFill>
                   <a:srgbClr val="2563EB"/>
                 </a:solidFill>
               </a:rPr>
-              <a:t>• Core Vision:</a:t>
-            </a:r>
-            <a:r>
-              <a:rPr b="0" sz="1000">
+              <a:t>• Direct Landing Experience:</a:t>
+            </a:r>
+            <a:r>
+              <a:rPr b="0" sz="950">
                 <a:solidFill>
                   <a:srgbClr val="334155"/>
                 </a:solidFill>
               </a:rPr>
-              <a:t> Engineered an interactive, full-stack enterprise platform consolidating workforce management, self-service portals, and operational telemetry.</a:t>
+              <a:t> Direct entry into the executive HR Director panel on initial site visit without mandatory login roadblocks.</a:t>
             </a:r>
           </a:p>
           <a:p>
@@ -3419,20 +3419,20 @@
               </a:spcAft>
             </a:pPr>
             <a:r>
-              <a:rPr b="1" sz="1050">
+              <a:rPr b="1" sz="1000">
                 <a:solidFill>
                   <a:srgbClr val="2563EB"/>
                 </a:solidFill>
               </a:rPr>
-              <a:t>• ZOHO People Alignment:</a:t>
-            </a:r>
-            <a:r>
-              <a:rPr b="0" sz="1000">
+              <a:t>• Enterprise Architecture:</a:t>
+            </a:r>
+            <a:r>
+              <a:rPr b="0" sz="950">
                 <a:solidFill>
                   <a:srgbClr val="334155"/>
                 </a:solidFill>
               </a:rPr>
-              <a:t> Inspired by enterprise human resource management tools with role-specific views and modular self-service workflows.</a:t>
+              <a:t> Built to match Zoho People and Google Workspace standards with role-specific views and modular workflows.</a:t>
             </a:r>
           </a:p>
           <a:p>
@@ -3442,20 +3442,20 @@
               </a:spcAft>
             </a:pPr>
             <a:r>
-              <a:rPr b="1" sz="1050">
+              <a:rPr b="1" sz="1000">
                 <a:solidFill>
                   <a:srgbClr val="2563EB"/>
                 </a:solidFill>
               </a:rPr>
-              <a:t>• Desktop-Optimized Experience:</a:t>
-            </a:r>
-            <a:r>
-              <a:rPr b="0" sz="1000">
+              <a:t>• Widescreen Sticky Layout:</a:t>
+            </a:r>
+            <a:r>
+              <a:rPr b="0" sz="950">
                 <a:solidFill>
                   <a:srgbClr val="334155"/>
                 </a:solidFill>
               </a:rPr>
-              <a:t> Redesigned with a sticky top navigation header and wide responsive layout, maximizing screen efficiency without side margin waste.</a:t>
+              <a:t> Replaced sidebars with a sticky top navigation menu, maximizing horizontal desktop space.</a:t>
             </a:r>
           </a:p>
           <a:p>
@@ -3465,7 +3465,7 @@
               </a:spcAft>
             </a:pPr>
             <a:r>
-              <a:rPr b="1" sz="1050">
+              <a:rPr b="1" sz="1000">
                 <a:solidFill>
                   <a:srgbClr val="2563EB"/>
                 </a:solidFill>
@@ -3473,12 +3473,12 @@
               <a:t>• Real-Time KPI Calibration:</a:t>
             </a:r>
             <a:r>
-              <a:rPr b="0" sz="1000">
+              <a:rPr b="0" sz="950">
                 <a:solidFill>
                   <a:srgbClr val="334155"/>
                 </a:solidFill>
               </a:rPr>
-              <a:t> Enables dynamic tracking of employee tasks, decimal performance reviews, and live composite score derivations.</a:t>
+              <a:t> Dynamic deliverable tracking, decimal performance ratings (0.0-10.0), and live composite score derivations.</a:t>
             </a:r>
           </a:p>
           <a:p>
@@ -3488,20 +3488,20 @@
               </a:spcAft>
             </a:pPr>
             <a:r>
-              <a:rPr b="1" sz="1050">
+              <a:rPr b="1" sz="1000">
                 <a:solidFill>
                   <a:srgbClr val="2563EB"/>
                 </a:solidFill>
               </a:rPr>
-              <a:t>• Standardized Roster:</a:t>
-            </a:r>
-            <a:r>
-              <a:rPr b="0" sz="1000">
+              <a:t>• Indian Workforce Dataset:</a:t>
+            </a:r>
+            <a:r>
+              <a:rPr b="0" sz="950">
                 <a:solidFill>
                   <a:srgbClr val="334155"/>
                 </a:solidFill>
               </a:rPr>
-              <a:t> Pre-configured with a 15-member Indian workforce dataset, complete with reporting lines, compensation, and departmental structures.</a:t>
+              <a:t> Pre-configured with a 15-member Indian corporate roster, reporting lines, compensation CTC, and departments.</a:t>
             </a:r>
           </a:p>
         </p:txBody>
@@ -3577,7 +3577,7 @@
               <a:spcAft>
                 <a:spcPts val="200"/>
               </a:spcAft>
-              <a:defRPr sz="1350" b="1">
+              <a:defRPr sz="1300" b="1">
                 <a:solidFill>
                   <a:srgbClr val="0F172A"/>
                 </a:solidFill>
@@ -3592,7 +3592,7 @@
               <a:spcAft>
                 <a:spcPts val="800"/>
               </a:spcAft>
-              <a:defRPr sz="1000">
+              <a:defRPr sz="950">
                 <a:solidFill>
                   <a:srgbClr val="64748B"/>
                 </a:solidFill>
@@ -3609,7 +3609,7 @@
               </a:spcAft>
             </a:pPr>
             <a:r>
-              <a:rPr b="1" sz="1050">
+              <a:rPr b="1" sz="1000">
                 <a:solidFill>
                   <a:srgbClr val="2563EB"/>
                 </a:solidFill>
@@ -3617,12 +3617,12 @@
               <a:t>• Fragmented Tooling:</a:t>
             </a:r>
             <a:r>
-              <a:rPr b="0" sz="1000">
+              <a:rPr b="0" sz="950">
                 <a:solidFill>
                   <a:srgbClr val="334155"/>
                 </a:solidFill>
               </a:rPr>
-              <a:t> Legacy HR operations rely on disconnected spreadsheets and manual email approvals, causing operational latency and tracking errors.</a:t>
+              <a:t> Legacy HR operations rely on disconnected spreadsheets and manual email approvals, causing operational latency.</a:t>
             </a:r>
           </a:p>
           <a:p>
@@ -3632,7 +3632,7 @@
               </a:spcAft>
             </a:pPr>
             <a:r>
-              <a:rPr b="1" sz="1050">
+              <a:rPr b="1" sz="1000">
                 <a:solidFill>
                   <a:srgbClr val="2563EB"/>
                 </a:solidFill>
@@ -3640,12 +3640,12 @@
               <a:t>• Rigid Role Boundaries:</a:t>
             </a:r>
             <a:r>
-              <a:rPr b="0" sz="1000">
+              <a:rPr b="0" sz="950">
                 <a:solidFill>
                   <a:srgbClr val="334155"/>
                 </a:solidFill>
               </a:rPr>
-              <a:t> Off-the-shelf software often lacks granular Role-Based Access Control (RBAC), exposing sensitive structural data to employees.</a:t>
+              <a:t> Off-the-shelf software often lacks granular Role-Based Access Control (RBAC), exposing sensitive hierarchy data.</a:t>
             </a:r>
           </a:p>
           <a:p>
@@ -3655,7 +3655,7 @@
               </a:spcAft>
             </a:pPr>
             <a:r>
-              <a:rPr b="1" sz="1050">
+              <a:rPr b="1" sz="1000">
                 <a:solidFill>
                   <a:srgbClr val="2563EB"/>
                 </a:solidFill>
@@ -3663,12 +3663,12 @@
               <a:t>• Opaque Evaluation Metrics:</a:t>
             </a:r>
             <a:r>
-              <a:rPr b="0" sz="1000">
+              <a:rPr b="0" sz="950">
                 <a:solidFill>
                   <a:srgbClr val="334155"/>
                 </a:solidFill>
               </a:rPr>
-              <a:t> Performance grading is often calculated via hidden or static annual formulas rather than transparent, sprint-based deliverables.</a:t>
+              <a:t> Performance grading is often calculated via hidden static annual formulas rather than transparent deliverables.</a:t>
             </a:r>
           </a:p>
           <a:p>
@@ -3678,7 +3678,7 @@
               </a:spcAft>
             </a:pPr>
             <a:r>
-              <a:rPr b="1" sz="1050">
+              <a:rPr b="1" sz="1000">
                 <a:solidFill>
                   <a:srgbClr val="2563EB"/>
                 </a:solidFill>
@@ -3686,12 +3686,12 @@
               <a:t>• Cluttered User Interfaces:</a:t>
             </a:r>
             <a:r>
-              <a:rPr b="0" sz="1000">
+              <a:rPr b="0" sz="950">
                 <a:solidFill>
                   <a:srgbClr val="334155"/>
                 </a:solidFill>
               </a:rPr>
-              <a:t> Many enterprise portals suffer from tall, scroll-heavy sidebars and wasted desktop margins, diminishing daily usability.</a:t>
+              <a:t> Enterprise portals suffer from tall, scroll-heavy sidebars and wasted desktop margins, diminishing daily usability.</a:t>
             </a:r>
           </a:p>
           <a:p>
@@ -3701,7 +3701,7 @@
               </a:spcAft>
             </a:pPr>
             <a:r>
-              <a:rPr b="1" sz="1050">
+              <a:rPr b="1" sz="1000">
                 <a:solidFill>
                   <a:srgbClr val="2563EB"/>
                 </a:solidFill>
@@ -3709,12 +3709,12 @@
               <a:t>• Absence of Instant Recovery:</a:t>
             </a:r>
             <a:r>
-              <a:rPr b="0" sz="1000">
+              <a:rPr b="0" sz="950">
                 <a:solidFill>
                   <a:srgbClr val="334155"/>
                 </a:solidFill>
               </a:rPr>
-              <a:t> Lack of standardized demonstration datasets and instant persistence resets complicates training and stakeholder evaluation.</a:t>
+              <a:t> Lack of standardized demonstration datasets and instant persistence resets complicates stakeholder evaluation.</a:t>
             </a:r>
           </a:p>
         </p:txBody>
@@ -3790,7 +3790,7 @@
               <a:spcAft>
                 <a:spcPts val="200"/>
               </a:spcAft>
-              <a:defRPr sz="1350" b="1">
+              <a:defRPr sz="1300" b="1">
                 <a:solidFill>
                   <a:srgbClr val="0F172A"/>
                 </a:solidFill>
@@ -3805,7 +3805,7 @@
               <a:spcAft>
                 <a:spcPts val="800"/>
               </a:spcAft>
-              <a:defRPr sz="1000">
+              <a:defRPr sz="950">
                 <a:solidFill>
                   <a:srgbClr val="64748B"/>
                 </a:solidFill>
@@ -3822,7 +3822,7 @@
               </a:spcAft>
             </a:pPr>
             <a:r>
-              <a:rPr b="1" sz="1050">
+              <a:rPr b="1" sz="1000">
                 <a:solidFill>
                   <a:srgbClr val="2563EB"/>
                 </a:solidFill>
@@ -3830,12 +3830,12 @@
               <a:t>• Frontend Application:</a:t>
             </a:r>
             <a:r>
-              <a:rPr b="0" sz="1000">
+              <a:rPr b="0" sz="950">
                 <a:solidFill>
                   <a:srgbClr val="334155"/>
                 </a:solidFill>
               </a:rPr>
-              <a:t> Built with React 18, Vite build tool, and Tailwind CSS for a modern, responsive user experience.</a:t>
+              <a:t> Built with React 18, Vite 8 build tool, and Tailwind CSS for a modern, responsive user experience.</a:t>
             </a:r>
           </a:p>
           <a:p>
@@ -3845,7 +3845,7 @@
               </a:spcAft>
             </a:pPr>
             <a:r>
-              <a:rPr b="1" sz="1050">
+              <a:rPr b="1" sz="1000">
                 <a:solidFill>
                   <a:srgbClr val="2563EB"/>
                 </a:solidFill>
@@ -3853,7 +3853,7 @@
               <a:t>• Data Visualization:</a:t>
             </a:r>
             <a:r>
-              <a:rPr b="0" sz="1000">
+              <a:rPr b="0" sz="950">
                 <a:solidFill>
                   <a:srgbClr val="334155"/>
                 </a:solidFill>
@@ -3868,7 +3868,7 @@
               </a:spcAft>
             </a:pPr>
             <a:r>
-              <a:rPr b="1" sz="1050">
+              <a:rPr b="1" sz="1000">
                 <a:solidFill>
                   <a:srgbClr val="2563EB"/>
                 </a:solidFill>
@@ -3876,7 +3876,7 @@
               <a:t>• Backend Server &amp; API:</a:t>
             </a:r>
             <a:r>
-              <a:rPr b="0" sz="1000">
+              <a:rPr b="0" sz="950">
                 <a:solidFill>
                   <a:srgbClr val="334155"/>
                 </a:solidFill>
@@ -3891,7 +3891,7 @@
               </a:spcAft>
             </a:pPr>
             <a:r>
-              <a:rPr b="1" sz="1050">
+              <a:rPr b="1" sz="1000">
                 <a:solidFill>
                   <a:srgbClr val="2563EB"/>
                 </a:solidFill>
@@ -3899,7 +3899,7 @@
               <a:t>• Database Engine:</a:t>
             </a:r>
             <a:r>
-              <a:rPr b="0" sz="1000">
+              <a:rPr b="0" sz="950">
                 <a:solidFill>
                   <a:srgbClr val="334155"/>
                 </a:solidFill>
@@ -3914,7 +3914,7 @@
               </a:spcAft>
             </a:pPr>
             <a:r>
-              <a:rPr b="1" sz="1050">
+              <a:rPr b="1" sz="1000">
                 <a:solidFill>
                   <a:srgbClr val="2563EB"/>
                 </a:solidFill>
@@ -3922,7 +3922,7 @@
               <a:t>• Enterprise RBAC:</a:t>
             </a:r>
             <a:r>
-              <a:rPr b="0" sz="1000">
+              <a:rPr b="0" sz="950">
                 <a:solidFill>
                   <a:srgbClr val="334155"/>
                 </a:solidFill>
@@ -3937,7 +3937,7 @@
               </a:spcAft>
             </a:pPr>
             <a:r>
-              <a:rPr b="1" sz="1050">
+              <a:rPr b="1" sz="1000">
                 <a:solidFill>
                   <a:srgbClr val="2563EB"/>
                 </a:solidFill>
@@ -3945,7 +3945,7 @@
               <a:t>• Data Persistence:</a:t>
             </a:r>
             <a:r>
-              <a:rPr b="0" sz="1000">
+              <a:rPr b="0" sz="950">
                 <a:solidFill>
                   <a:srgbClr val="334155"/>
                 </a:solidFill>
@@ -4135,7 +4135,7 @@
               </a:defRPr>
             </a:pPr>
             <a:r>
-              <a:t>Comprehensive walkthrough of the platform modules, navigation flow, and functional capabilities</a:t>
+              <a:t>Modular architecture partitioned across HR Director, Engineering Manager, and Employee workspaces</a:t>
             </a:r>
           </a:p>
         </p:txBody>
@@ -4246,14 +4246,14 @@
               <a:spcAft>
                 <a:spcPts val="200"/>
               </a:spcAft>
-              <a:defRPr sz="1350" b="1">
+              <a:defRPr sz="1300" b="1">
                 <a:solidFill>
                   <a:srgbClr val="0F172A"/>
                 </a:solidFill>
               </a:defRPr>
             </a:pPr>
             <a:r>
-              <a:t>Two-Phase Access &amp; Sticky Navigation</a:t>
+              <a:t>HR Director: Governance &amp; Operations</a:t>
             </a:r>
           </a:p>
           <a:p>
@@ -4261,83 +4261,106 @@
               <a:spcAft>
                 <a:spcPts val="800"/>
               </a:spcAft>
-              <a:defRPr sz="1000">
+              <a:defRPr sz="950">
                 <a:solidFill>
                   <a:srgbClr val="64748B"/>
                 </a:solidFill>
               </a:defRPr>
             </a:pPr>
             <a:r>
-              <a:t>User registration and layout hierarchy</a:t>
-            </a:r>
-          </a:p>
-          <a:p>
-            <a:pPr>
-              <a:spcAft>
-                <a:spcPts val="300"/>
-              </a:spcAft>
-            </a:pPr>
-            <a:r>
-              <a:rPr b="1" sz="1000">
+              <a:t>7 comprehensive management modules</a:t>
+            </a:r>
+          </a:p>
+          <a:p>
+            <a:pPr>
+              <a:spcAft>
+                <a:spcPts val="250"/>
+              </a:spcAft>
+            </a:pPr>
+            <a:r>
+              <a:rPr b="1" sz="950">
                 <a:solidFill>
                   <a:srgbClr val="2563EB"/>
                 </a:solidFill>
               </a:rPr>
-              <a:t>• Registration Approval Gateway:</a:t>
-            </a:r>
-            <a:r>
-              <a:rPr sz="950">
+              <a:t>• Organization &amp; Employee Directory:</a:t>
+            </a:r>
+            <a:r>
+              <a:rPr sz="900">
                 <a:solidFill>
                   <a:srgbClr val="334155"/>
                 </a:solidFill>
               </a:rPr>
-              <a:t> New user sign-ups are flagged as Pending and cannot log in until verified and authorized by the HR Director.</a:t>
-            </a:r>
-          </a:p>
-          <a:p>
-            <a:pPr>
-              <a:spcAft>
-                <a:spcPts val="300"/>
-              </a:spcAft>
-            </a:pPr>
-            <a:r>
-              <a:rPr b="1" sz="1000">
+              <a:t> Unified personnel directory and 3-in-1 organizational reporting tree with granular profile editing.</a:t>
+            </a:r>
+          </a:p>
+          <a:p>
+            <a:pPr>
+              <a:spcAft>
+                <a:spcPts val="250"/>
+              </a:spcAft>
+            </a:pPr>
+            <a:r>
+              <a:rPr b="1" sz="950">
                 <a:solidFill>
                   <a:srgbClr val="2563EB"/>
                 </a:solidFill>
               </a:rPr>
-              <a:t>• Sticky Top Navigation Bar:</a:t>
-            </a:r>
-            <a:r>
-              <a:rPr sz="950">
+              <a:t>• Onboarding &amp; Offboarding (HR Process):</a:t>
+            </a:r>
+            <a:r>
+              <a:rPr sz="900">
                 <a:solidFill>
                   <a:srgbClr val="334155"/>
                 </a:solidFill>
               </a:rPr>
-              <a:t> Horizontal menu fixed at the top of the viewport; stays locked during scroll and eliminates left-sidebar whitespace waste.</a:t>
-            </a:r>
-          </a:p>
-          <a:p>
-            <a:pPr>
-              <a:spcAft>
-                <a:spcPts val="300"/>
-              </a:spcAft>
-            </a:pPr>
-            <a:r>
-              <a:rPr b="1" sz="1000">
+              <a:t> Interactive checklist tracking for documentation, IT assets provisioning, and exit clearances.</a:t>
+            </a:r>
+          </a:p>
+          <a:p>
+            <a:pPr>
+              <a:spcAft>
+                <a:spcPts val="250"/>
+              </a:spcAft>
+            </a:pPr>
+            <a:r>
+              <a:rPr b="1" sz="950">
                 <a:solidFill>
                   <a:srgbClr val="2563EB"/>
                 </a:solidFill>
               </a:rPr>
-              <a:t>• Active Status Display:</a:t>
-            </a:r>
-            <a:r>
-              <a:rPr sz="950">
+              <a:t>• Time &amp; Attendance Administration:</a:t>
+            </a:r>
+            <a:r>
+              <a:rPr sz="900">
                 <a:solidFill>
                   <a:srgbClr val="334155"/>
                 </a:solidFill>
               </a:rPr>
-              <a:t> Instant dropdown role switching replaced with a static status indicator; users sign out and log in to change roles.</a:t>
+              <a:t> Presence compliance monitor and leave authorization queue with start/end date constraints.</a:t>
+            </a:r>
+          </a:p>
+          <a:p>
+            <a:pPr>
+              <a:spcAft>
+                <a:spcPts val="250"/>
+              </a:spcAft>
+            </a:pPr>
+            <a:r>
+              <a:rPr b="1" sz="950">
+                <a:solidFill>
+                  <a:srgbClr val="2563EB"/>
+                </a:solidFill>
+              </a:rPr>
+              <a:t>• Talent Management &amp; Appraisals:</a:t>
+            </a:r>
+            <a:r>
+              <a:rPr sz="900">
+                <a:solidFill>
+                  <a:srgbClr val="334155"/>
+                </a:solidFill>
+              </a:rPr>
+              <a:t> Real-time KPI simulator, decimal reviews (0.0-10.0), 9-box talent matrix, and appraisal dispatch.</a:t>
             </a:r>
           </a:p>
         </p:txBody>
@@ -4413,14 +4436,14 @@
               <a:spcAft>
                 <a:spcPts val="200"/>
               </a:spcAft>
-              <a:defRPr sz="1350" b="1">
+              <a:defRPr sz="1300" b="1">
                 <a:solidFill>
                   <a:srgbClr val="0F172A"/>
                 </a:solidFill>
               </a:defRPr>
             </a:pPr>
             <a:r>
-              <a:t>Operations Cockpit &amp; Employee Directory</a:t>
+              <a:t>HR Director: Services &amp; Intelligence</a:t>
             </a:r>
           </a:p>
           <a:p>
@@ -4428,83 +4451,106 @@
               <a:spcAft>
                 <a:spcPts val="800"/>
               </a:spcAft>
-              <a:defRPr sz="1000">
+              <a:defRPr sz="950">
                 <a:solidFill>
                   <a:srgbClr val="64748B"/>
                 </a:solidFill>
               </a:defRPr>
             </a:pPr>
             <a:r>
-              <a:t>Executive oversight and personnel calibration</a:t>
-            </a:r>
-          </a:p>
-          <a:p>
-            <a:pPr>
-              <a:spcAft>
-                <a:spcPts val="300"/>
-              </a:spcAft>
-            </a:pPr>
-            <a:r>
-              <a:rPr b="1" sz="1000">
+              <a:t>Employee relations and executive telemetry</a:t>
+            </a:r>
+          </a:p>
+          <a:p>
+            <a:pPr>
+              <a:spcAft>
+                <a:spcPts val="250"/>
+              </a:spcAft>
+            </a:pPr>
+            <a:r>
+              <a:rPr b="1" sz="950">
                 <a:solidFill>
                   <a:srgbClr val="2563EB"/>
                 </a:solidFill>
               </a:rPr>
-              <a:t>• Executive Workforce Cockpit:</a:t>
-            </a:r>
-            <a:r>
-              <a:rPr sz="950">
+              <a:t>• HR Help Desk &amp; Requests:</a:t>
+            </a:r>
+            <a:r>
+              <a:rPr sz="900">
                 <a:solidFill>
                   <a:srgbClr val="334155"/>
                 </a:solidFill>
               </a:rPr>
-              <a:t> 6-month historical attendance compliance trajectory, radar department benchmarks, and KPI tier distribution.</a:t>
-            </a:r>
-          </a:p>
-          <a:p>
-            <a:pPr>
-              <a:spcAft>
-                <a:spcPts val="300"/>
-              </a:spcAft>
-            </a:pPr>
-            <a:r>
-              <a:rPr b="1" sz="1000">
+              <a:t> Triage employee support tickets (Payroll, Leave, IT, Policies) with tracked resolution notes.</a:t>
+            </a:r>
+          </a:p>
+          <a:p>
+            <a:pPr>
+              <a:spcAft>
+                <a:spcPts val="250"/>
+              </a:spcAft>
+            </a:pPr>
+            <a:r>
+              <a:rPr b="1" sz="950">
                 <a:solidFill>
                   <a:srgbClr val="2563EB"/>
                 </a:solidFill>
               </a:rPr>
-              <a:t>• Shifted Leadership Roster:</a:t>
-            </a:r>
-            <a:r>
-              <a:rPr sz="950">
+              <a:t>• Files &amp; Document Management:</a:t>
+            </a:r>
+            <a:r>
+              <a:rPr sz="900">
                 <a:solidFill>
                   <a:srgbClr val="334155"/>
                 </a:solidFill>
               </a:rPr>
-              <a:t> Top Performers Leaderboard positioned on the left column for immediate visibility.</a:t>
-            </a:r>
-          </a:p>
-          <a:p>
-            <a:pPr>
-              <a:spcAft>
-                <a:spcPts val="300"/>
-              </a:spcAft>
-            </a:pPr>
-            <a:r>
-              <a:rPr b="1" sz="1000">
+              <a:t> Enterprise repository for company policies, POSH handbooks, NDA templates, and tax declarations.</a:t>
+            </a:r>
+          </a:p>
+          <a:p>
+            <a:pPr>
+              <a:spcAft>
+                <a:spcPts val="250"/>
+              </a:spcAft>
+            </a:pPr>
+            <a:r>
+              <a:rPr b="1" sz="950">
                 <a:solidFill>
                   <a:srgbClr val="2563EB"/>
                 </a:solidFill>
               </a:rPr>
-              <a:t>• Expanded HR Field Calibration:</a:t>
-            </a:r>
-            <a:r>
-              <a:rPr sz="950">
+              <a:t>• Analytics &amp; Reports:</a:t>
+            </a:r>
+            <a:r>
+              <a:rPr sz="900">
                 <a:solidFill>
                   <a:srgbClr val="334155"/>
                 </a:solidFill>
               </a:rPr>
-              <a:t> HR can adjust Role Title, Department Assignment, Annual CTC (INR), Status, Location, Manager, and Work Mode.</a:t>
+              <a:t> Executive operations cockpit, 6-month attendance trajectory, strategic insights, and CSV exports.</a:t>
+            </a:r>
+          </a:p>
+          <a:p>
+            <a:pPr>
+              <a:spcAft>
+                <a:spcPts val="250"/>
+              </a:spcAft>
+            </a:pPr>
+            <a:r>
+              <a:rPr b="1" sz="950">
+                <a:solidFill>
+                  <a:srgbClr val="2563EB"/>
+                </a:solidFill>
+              </a:rPr>
+              <a:t>• Reset Demo Capability:</a:t>
+            </a:r>
+            <a:r>
+              <a:rPr sz="900">
+                <a:solidFill>
+                  <a:srgbClr val="334155"/>
+                </a:solidFill>
+              </a:rPr>
+              <a:t> Persistent database modifications with a 1-click Reset Demo button to restore standard data.</a:t>
             </a:r>
           </a:p>
         </p:txBody>
@@ -4580,14 +4626,14 @@
               <a:spcAft>
                 <a:spcPts val="200"/>
               </a:spcAft>
-              <a:defRPr sz="1350" b="1">
+              <a:defRPr sz="1300" b="1">
                 <a:solidFill>
                   <a:srgbClr val="0F172A"/>
                 </a:solidFill>
               </a:defRPr>
             </a:pPr>
             <a:r>
-              <a:t>Real-Time KPI Simulator &amp; Formula Abstraction</a:t>
+              <a:t>Engineering Manager: Sprint Oversight</a:t>
             </a:r>
           </a:p>
           <a:p>
@@ -4595,106 +4641,106 @@
               <a:spcAft>
                 <a:spcPts val="800"/>
               </a:spcAft>
-              <a:defRPr sz="1000">
+              <a:defRPr sz="950">
                 <a:solidFill>
                   <a:srgbClr val="64748B"/>
                 </a:solidFill>
               </a:defRPr>
             </a:pPr>
             <a:r>
-              <a:t>Interactive performance modeling without formulas</a:t>
-            </a:r>
-          </a:p>
-          <a:p>
-            <a:pPr>
-              <a:spcAft>
-                <a:spcPts val="300"/>
-              </a:spcAft>
-            </a:pPr>
-            <a:r>
-              <a:rPr b="1" sz="1000">
+              <a:t>4 dedicated managerial supervisory modules</a:t>
+            </a:r>
+          </a:p>
+          <a:p>
+            <a:pPr>
+              <a:spcAft>
+                <a:spcPts val="250"/>
+              </a:spcAft>
+            </a:pPr>
+            <a:r>
+              <a:rPr b="1" sz="950">
                 <a:solidFill>
                   <a:srgbClr val="2563EB"/>
                 </a:solidFill>
               </a:rPr>
-              <a:t>• Real-Time Deliverable Sync:</a:t>
-            </a:r>
-            <a:r>
-              <a:rPr sz="950">
+              <a:t>• Approval Center:</a:t>
+            </a:r>
+            <a:r>
+              <a:rPr sz="900">
                 <a:solidFill>
                   <a:srgbClr val="334155"/>
                 </a:solidFill>
               </a:rPr>
-              <a:t> Adjusting Assigned Deliverables automatically syncs and clamps Completed Deliverables in real time.</a:t>
-            </a:r>
-          </a:p>
-          <a:p>
-            <a:pPr>
-              <a:spcAft>
-                <a:spcPts val="300"/>
-              </a:spcAft>
-            </a:pPr>
-            <a:r>
-              <a:rPr b="1" sz="1000">
+              <a:t> Timesheet hour sign-offs and team leave review (monitoring presence while HR retains final approval authority).</a:t>
+            </a:r>
+          </a:p>
+          <a:p>
+            <a:pPr>
+              <a:spcAft>
+                <a:spcPts val="250"/>
+              </a:spcAft>
+            </a:pPr>
+            <a:r>
+              <a:rPr b="1" sz="950">
                 <a:solidFill>
                   <a:srgbClr val="2563EB"/>
                 </a:solidFill>
               </a:rPr>
-              <a:t>• Full-Range Attendance:</a:t>
-            </a:r>
-            <a:r>
-              <a:rPr sz="950">
+              <a:t>• Team Supervision:</a:t>
+            </a:r>
+            <a:r>
+              <a:rPr sz="900">
                 <a:solidFill>
                   <a:srgbClr val="334155"/>
                 </a:solidFill>
               </a:rPr>
-              <a:t> Attendance compliance slider supports values from 0% to 100% with immediate index recalculation.</a:t>
-            </a:r>
-          </a:p>
-          <a:p>
-            <a:pPr>
-              <a:spcAft>
-                <a:spcPts val="300"/>
-              </a:spcAft>
-            </a:pPr>
-            <a:r>
-              <a:rPr b="1" sz="1000">
+              <a:t> Dedicated engineering roster oversight, live presence monitoring (On-site, Hybrid, Remote), and task delegation.</a:t>
+            </a:r>
+          </a:p>
+          <a:p>
+            <a:pPr>
+              <a:spcAft>
+                <a:spcPts val="250"/>
+              </a:spcAft>
+            </a:pPr>
+            <a:r>
+              <a:rPr b="1" sz="950">
                 <a:solidFill>
                   <a:srgbClr val="2563EB"/>
                 </a:solidFill>
               </a:rPr>
-              <a:t>• Managerial Decimal Reviews:</a:t>
-            </a:r>
-            <a:r>
-              <a:rPr sz="950">
+              <a:t>• Performance &amp; Goal Tracking:</a:t>
+            </a:r>
+            <a:r>
+              <a:rPr sz="900">
                 <a:solidFill>
                   <a:srgbClr val="334155"/>
                 </a:solidFill>
               </a:rPr>
-              <a:t> Ratings on a 0.0 to 10.0 scale with 0.1 precision steps for nuanced quarterly evaluations.</a:t>
-            </a:r>
-          </a:p>
-          <a:p>
-            <a:pPr>
-              <a:spcAft>
-                <a:spcPts val="300"/>
-              </a:spcAft>
-            </a:pPr>
-            <a:r>
-              <a:rPr b="1" sz="1000">
+              <a:t> Team sprint velocity, overall team KPI benchmark, decimal review calibrator, and quarterly OKRs.</a:t>
+            </a:r>
+          </a:p>
+          <a:p>
+            <a:pPr>
+              <a:spcAft>
+                <a:spcPts val="250"/>
+              </a:spcAft>
+            </a:pPr>
+            <a:r>
+              <a:rPr b="1" sz="950">
                 <a:solidFill>
                   <a:srgbClr val="2563EB"/>
                 </a:solidFill>
               </a:rPr>
-              <a:t>• Clean Mathematical Abstraction:</a:t>
-            </a:r>
-            <a:r>
-              <a:rPr sz="950">
+              <a:t>• Time Logs &amp; Projects:</a:t>
+            </a:r>
+            <a:r>
+              <a:rPr sz="900">
                 <a:solidFill>
                   <a:srgbClr val="334155"/>
                 </a:solidFill>
               </a:rPr>
-              <a:t> Raw formulas are completely hidden behind clean visual progress indicators and tier grades.</a:t>
+              <a:t> Project deliverable boards, team hours burn-down, sprint completion rates, and blocker resolution.</a:t>
             </a:r>
           </a:p>
         </p:txBody>
@@ -4770,14 +4816,14 @@
               <a:spcAft>
                 <a:spcPts val="200"/>
               </a:spcAft>
-              <a:defRPr sz="1350" b="1">
+              <a:defRPr sz="1300" b="1">
                 <a:solidFill>
                   <a:srgbClr val="0F172A"/>
                 </a:solidFill>
               </a:defRPr>
             </a:pPr>
             <a:r>
-              <a:t>Leave Management &amp; Employee Self-Service</a:t>
+              <a:t>Employee Self-Service Portal</a:t>
             </a:r>
           </a:p>
           <a:p>
@@ -4785,106 +4831,129 @@
               <a:spcAft>
                 <a:spcPts val="800"/>
               </a:spcAft>
-              <a:defRPr sz="1000">
+              <a:defRPr sz="950">
                 <a:solidFill>
                   <a:srgbClr val="64748B"/>
                 </a:solidFill>
               </a:defRPr>
             </a:pPr>
             <a:r>
-              <a:t>Time off governance and personalized views</a:t>
-            </a:r>
-          </a:p>
-          <a:p>
-            <a:pPr>
-              <a:spcAft>
-                <a:spcPts val="300"/>
-              </a:spcAft>
-            </a:pPr>
-            <a:r>
-              <a:rPr b="1" sz="1000">
+              <a:t>5 specialized employee self-service modules</a:t>
+            </a:r>
+          </a:p>
+          <a:p>
+            <a:pPr>
+              <a:spcAft>
+                <a:spcPts val="250"/>
+              </a:spcAft>
+            </a:pPr>
+            <a:r>
+              <a:rPr b="1" sz="950">
                 <a:solidFill>
                   <a:srgbClr val="2563EB"/>
                 </a:solidFill>
               </a:rPr>
-              <a:t>• Date Validation &amp; Auto-Duration:</a:t>
-            </a:r>
-            <a:r>
-              <a:rPr sz="950">
+              <a:t>• Self Attendance &amp; Leave:</a:t>
+            </a:r>
+            <a:r>
+              <a:rPr sz="900">
                 <a:solidFill>
                   <a:srgbClr val="334155"/>
                 </a:solidFill>
               </a:rPr>
-              <a:t> Selecting leave dates auto-computes total days; end date enforces start-date boundary constraints.</a:t>
-            </a:r>
-          </a:p>
-          <a:p>
-            <a:pPr>
-              <a:spcAft>
-                <a:spcPts val="300"/>
-              </a:spcAft>
-            </a:pPr>
-            <a:r>
-              <a:rPr b="1" sz="1000">
+              <a:t> Live punch clock-in/out simulator, leave balances (CL, SL, PL), and time-off request submission.</a:t>
+            </a:r>
+          </a:p>
+          <a:p>
+            <a:pPr>
+              <a:spcAft>
+                <a:spcPts val="250"/>
+              </a:spcAft>
+            </a:pPr>
+            <a:r>
+              <a:rPr b="1" sz="950">
                 <a:solidFill>
                   <a:srgbClr val="2563EB"/>
                 </a:solidFill>
               </a:rPr>
-              <a:t>• Strict HR Approval Authority:</a:t>
-            </a:r>
-            <a:r>
-              <a:rPr sz="950">
+              <a:t>• Time Tracking:</a:t>
+            </a:r>
+            <a:r>
+              <a:rPr sz="900">
                 <a:solidFill>
                   <a:srgbClr val="334155"/>
                 </a:solidFill>
               </a:rPr>
-              <a:t> Only the HR Director can approve or decline leave; Engineering Managers are restricted to view-only access.</a:t>
-            </a:r>
-          </a:p>
-          <a:p>
-            <a:pPr>
-              <a:spcAft>
-                <a:spcPts val="300"/>
-              </a:spcAft>
-            </a:pPr>
-            <a:r>
-              <a:rPr b="1" sz="1000">
+              <a:t> Daily timesheet logger, logged hours history, and active sprint deliverables completion toggle.</a:t>
+            </a:r>
+          </a:p>
+          <a:p>
+            <a:pPr>
+              <a:spcAft>
+                <a:spcPts val="250"/>
+              </a:spcAft>
+            </a:pPr>
+            <a:r>
+              <a:rPr b="1" sz="950">
                 <a:solidFill>
                   <a:srgbClr val="2563EB"/>
                 </a:solidFill>
               </a:rPr>
-              <a:t>• Tailored Employee Views:</a:t>
-            </a:r>
-            <a:r>
-              <a:rPr sz="950">
+              <a:t>• Performance &amp; Self-Appraisal:</a:t>
+            </a:r>
+            <a:r>
+              <a:rPr sz="900">
                 <a:solidFill>
                   <a:srgbClr val="334155"/>
                 </a:solidFill>
               </a:rPr>
-              <a:t> Organization Tree hidden from employees; replaced with Past Feedbacks, Leaves, and Department Info.</a:t>
-            </a:r>
-          </a:p>
-          <a:p>
-            <a:pPr>
-              <a:spcAft>
-                <a:spcPts val="300"/>
-              </a:spcAft>
-            </a:pPr>
-            <a:r>
-              <a:rPr b="1" sz="1000">
+              <a:t> Personal KPI scorecard, quarterly self-evaluation submitter, and official HR appraisals timeline.</a:t>
+            </a:r>
+          </a:p>
+          <a:p>
+            <a:pPr>
+              <a:spcAft>
+                <a:spcPts val="250"/>
+              </a:spcAft>
+            </a:pPr>
+            <a:r>
+              <a:rPr b="1" sz="950">
                 <a:solidFill>
                   <a:srgbClr val="2563EB"/>
                 </a:solidFill>
               </a:rPr>
-              <a:t>• 3-Day Auto-Expiring Notifications:</a:t>
-            </a:r>
-            <a:r>
-              <a:rPr sz="950">
+              <a:t>• Profile &amp; Payroll Documents:</a:t>
+            </a:r>
+            <a:r>
+              <a:rPr sz="900">
                 <a:solidFill>
                   <a:srgbClr val="334155"/>
                 </a:solidFill>
               </a:rPr>
-              <a:t> Slide-out drawer displaying all unread messages with a 3-day retention lifecycle.</a:t>
+              <a:t> Digital employee badge, annual CTC breakdown (INR), and simulated monthly salary slip generator.</a:t>
+            </a:r>
+          </a:p>
+          <a:p>
+            <a:pPr>
+              <a:spcAft>
+                <a:spcPts val="250"/>
+              </a:spcAft>
+            </a:pPr>
+            <a:r>
+              <a:rPr b="1" sz="950">
+                <a:solidFill>
+                  <a:srgbClr val="2563EB"/>
+                </a:solidFill>
+              </a:rPr>
+              <a:t>• HR Tickets:</a:t>
+            </a:r>
+            <a:r>
+              <a:rPr sz="900">
+                <a:solidFill>
+                  <a:srgbClr val="334155"/>
+                </a:solidFill>
+              </a:rPr>
+              <a:t> Raise confidential support inquiries to HR with live status badges (Open, In Progress, Resolved).</a:t>
             </a:r>
           </a:p>
         </p:txBody>
@@ -5069,7 +5138,7 @@
               </a:defRPr>
             </a:pPr>
             <a:r>
-              <a:t>Novel architectural concepts realized in code along with the complete engineering toolkit</a:t>
+              <a:t>Technical concepts realized in code along with the complete engineering toolkit</a:t>
             </a:r>
           </a:p>
         </p:txBody>
@@ -5180,7 +5249,7 @@
               <a:spcAft>
                 <a:spcPts val="200"/>
               </a:spcAft>
-              <a:defRPr sz="1350" b="1">
+              <a:defRPr sz="1300" b="1">
                 <a:solidFill>
                   <a:srgbClr val="0F172A"/>
                 </a:solidFill>
@@ -5195,7 +5264,7 @@
               <a:spcAft>
                 <a:spcPts val="800"/>
               </a:spcAft>
-              <a:defRPr sz="1000">
+              <a:defRPr sz="950">
                 <a:solidFill>
                   <a:srgbClr val="64748B"/>
                 </a:solidFill>
@@ -5208,34 +5277,57 @@
           <a:p>
             <a:pPr>
               <a:spcAft>
-                <a:spcPts val="400"/>
-              </a:spcAft>
-            </a:pPr>
-            <a:r>
-              <a:rPr b="1" sz="1000">
+                <a:spcPts val="350"/>
+              </a:spcAft>
+            </a:pPr>
+            <a:r>
+              <a:rPr b="1" sz="950">
                 <a:solidFill>
                   <a:srgbClr val="2563EB"/>
                 </a:solidFill>
               </a:rPr>
+              <a:t>• Direct First-Time Landing:</a:t>
+            </a:r>
+            <a:r>
+              <a:rPr sz="900">
+                <a:solidFill>
+                  <a:srgbClr val="334155"/>
+                </a:solidFill>
+              </a:rPr>
+              <a:t> Automatic initialization into the HR Director dashboard on initial load, bypassing login barriers.</a:t>
+            </a:r>
+          </a:p>
+          <a:p>
+            <a:pPr>
+              <a:spcAft>
+                <a:spcPts val="350"/>
+              </a:spcAft>
+            </a:pPr>
+            <a:r>
+              <a:rPr b="1" sz="950">
+                <a:solidFill>
+                  <a:srgbClr val="2563EB"/>
+                </a:solidFill>
+              </a:rPr>
               <a:t>• Two-Phase Administrative Verification:</a:t>
             </a:r>
             <a:r>
-              <a:rPr sz="950">
+              <a:rPr sz="900">
                 <a:solidFill>
                   <a:srgbClr val="334155"/>
                 </a:solidFill>
               </a:rPr>
-              <a:t> Solved unverified account clutter by introducing a formal HR registration queue, preventing unapproved users from logging in until vetted.</a:t>
-            </a:r>
-          </a:p>
-          <a:p>
-            <a:pPr>
-              <a:spcAft>
-                <a:spcPts val="400"/>
-              </a:spcAft>
-            </a:pPr>
-            <a:r>
-              <a:rPr b="1" sz="1000">
+              <a:t> Formal HR registration queue preventing unapproved users from logging in until vetted.</a:t>
+            </a:r>
+          </a:p>
+          <a:p>
+            <a:pPr>
+              <a:spcAft>
+                <a:spcPts val="350"/>
+              </a:spcAft>
+            </a:pPr>
+            <a:r>
+              <a:rPr b="1" sz="950">
                 <a:solidFill>
                   <a:srgbClr val="2563EB"/>
                 </a:solidFill>
@@ -5243,45 +5335,45 @@
               <a:t>• Widescreen Sticky Navigation Paradigm:</a:t>
             </a:r>
             <a:r>
-              <a:rPr sz="950">
+              <a:rPr sz="900">
                 <a:solidFill>
                   <a:srgbClr val="334155"/>
                 </a:solidFill>
               </a:rPr>
-              <a:t> Transformed the traditional cramped sidebar into a horizontal sticky top bar, reclaiming 15% horizontal screen real estate for wide analytics panels.</a:t>
-            </a:r>
-          </a:p>
-          <a:p>
-            <a:pPr>
-              <a:spcAft>
-                <a:spcPts val="400"/>
-              </a:spcAft>
-            </a:pPr>
-            <a:r>
-              <a:rPr b="1" sz="1000">
+              <a:t> Transformed the traditional cramped sidebar into a horizontal sticky top bar, reclaiming 15% screen space.</a:t>
+            </a:r>
+          </a:p>
+          <a:p>
+            <a:pPr>
+              <a:spcAft>
+                <a:spcPts val="350"/>
+              </a:spcAft>
+            </a:pPr>
+            <a:r>
+              <a:rPr b="1" sz="950">
                 <a:solidFill>
                   <a:srgbClr val="2563EB"/>
                 </a:solidFill>
               </a:rPr>
-              <a:t>• Real-Time Numerical Input Synchronization:</a:t>
-            </a:r>
-            <a:r>
-              <a:rPr sz="950">
+              <a:t>• Real-Time Deliverable Synchronization:</a:t>
+            </a:r>
+            <a:r>
+              <a:rPr sz="900">
                 <a:solidFill>
                   <a:srgbClr val="334155"/>
                 </a:solidFill>
               </a:rPr>
-              <a:t> Implemented bidirectional dependency constraints between tasks assigned and tasks completed to eliminate invalid mathematical states.</a:t>
-            </a:r>
-          </a:p>
-          <a:p>
-            <a:pPr>
-              <a:spcAft>
-                <a:spcPts val="400"/>
-              </a:spcAft>
-            </a:pPr>
-            <a:r>
-              <a:rPr b="1" sz="1000">
+              <a:t> Implemented bidirectional constraints between tasks assigned and tasks completed.</a:t>
+            </a:r>
+          </a:p>
+          <a:p>
+            <a:pPr>
+              <a:spcAft>
+                <a:spcPts val="350"/>
+              </a:spcAft>
+            </a:pPr>
+            <a:r>
+              <a:rPr b="1" sz="950">
                 <a:solidFill>
                   <a:srgbClr val="2563EB"/>
                 </a:solidFill>
@@ -5289,22 +5381,22 @@
               <a:t>• Contextual Role Privacy Partitioning:</a:t>
             </a:r>
             <a:r>
-              <a:rPr sz="950">
+              <a:rPr sz="900">
                 <a:solidFill>
                   <a:srgbClr val="334155"/>
                 </a:solidFill>
               </a:rPr>
-              <a:t> Prevented unauthorized hierarchy browsing by replacing the organizational chart with employee-specific appraisal history and department mission cards.</a:t>
-            </a:r>
-          </a:p>
-          <a:p>
-            <a:pPr>
-              <a:spcAft>
-                <a:spcPts val="400"/>
-              </a:spcAft>
-            </a:pPr>
-            <a:r>
-              <a:rPr b="1" sz="1000">
+              <a:t> Prevented unauthorized hierarchy browsing by replacing the org chart with personal self-service views.</a:t>
+            </a:r>
+          </a:p>
+          <a:p>
+            <a:pPr>
+              <a:spcAft>
+                <a:spcPts val="350"/>
+              </a:spcAft>
+            </a:pPr>
+            <a:r>
+              <a:rPr b="1" sz="950">
                 <a:solidFill>
                   <a:srgbClr val="2563EB"/>
                 </a:solidFill>
@@ -5312,22 +5404,22 @@
               <a:t>• Time-Bound TTL Notification Lifecycle:</a:t>
             </a:r>
             <a:r>
-              <a:rPr sz="950">
+              <a:rPr sz="900">
                 <a:solidFill>
                   <a:srgbClr val="334155"/>
                 </a:solidFill>
               </a:rPr>
-              <a:t> Combined MongoDB native TTL indexes (259,200 seconds) with API date filters to maintain a clean 3-day operational audit window.</a:t>
-            </a:r>
-          </a:p>
-          <a:p>
-            <a:pPr>
-              <a:spcAft>
-                <a:spcPts val="400"/>
-              </a:spcAft>
-            </a:pPr>
-            <a:r>
-              <a:rPr b="1" sz="1000">
+              <a:t> Combined MongoDB native TTL indexes (259,200 seconds) with API date filters for a 3-day window.</a:t>
+            </a:r>
+          </a:p>
+          <a:p>
+            <a:pPr>
+              <a:spcAft>
+                <a:spcPts val="350"/>
+              </a:spcAft>
+            </a:pPr>
+            <a:r>
+              <a:rPr b="1" sz="950">
                 <a:solidFill>
                   <a:srgbClr val="2563EB"/>
                 </a:solidFill>
@@ -5335,35 +5427,35 @@
               <a:t>• Zero-Formula Presentation Layer:</a:t>
             </a:r>
             <a:r>
-              <a:rPr sz="950">
+              <a:rPr sz="900">
                 <a:solidFill>
                   <a:srgbClr val="334155"/>
                 </a:solidFill>
               </a:rPr>
-              <a:t> Abstracted complex arithmetic calculations into executive visual indicators, ensuring the interface remains clean and accessible.</a:t>
-            </a:r>
-          </a:p>
-          <a:p>
-            <a:pPr>
-              <a:spcAft>
-                <a:spcPts val="400"/>
-              </a:spcAft>
-            </a:pPr>
-            <a:r>
-              <a:rPr b="1" sz="1000">
+              <a:t> Abstracted complex arithmetic calculations into executive visual indicators.</a:t>
+            </a:r>
+          </a:p>
+          <a:p>
+            <a:pPr>
+              <a:spcAft>
+                <a:spcPts val="350"/>
+              </a:spcAft>
+            </a:pPr>
+            <a:r>
+              <a:rPr b="1" sz="950">
                 <a:solidFill>
                   <a:srgbClr val="2563EB"/>
                 </a:solidFill>
               </a:rPr>
-              <a:t>• On-Demand Demo State Reset:</a:t>
-            </a:r>
-            <a:r>
-              <a:rPr sz="950">
+              <a:t>• End-to-End Database Persistence:</a:t>
+            </a:r>
+            <a:r>
+              <a:rPr sz="900">
                 <a:solidFill>
                   <a:srgbClr val="334155"/>
                 </a:solidFill>
               </a:rPr>
-              <a:t> Integrated a persistent database model with a one-click Reset Demo button to restore standard Indian workforce records at any time.</a:t>
+              <a:t> Tickets, onboarding checklists, documents, and time logs persist across reloads.</a:t>
             </a:r>
           </a:p>
         </p:txBody>
@@ -5439,7 +5531,7 @@
               <a:spcAft>
                 <a:spcPts val="200"/>
               </a:spcAft>
-              <a:defRPr sz="1350" b="1">
+              <a:defRPr sz="1300" b="1">
                 <a:solidFill>
                   <a:srgbClr val="0F172A"/>
                 </a:solidFill>
@@ -5454,7 +5546,7 @@
               <a:spcAft>
                 <a:spcPts val="800"/>
               </a:spcAft>
-              <a:defRPr sz="1000">
+              <a:defRPr sz="950">
                 <a:solidFill>
                   <a:srgbClr val="64748B"/>
                 </a:solidFill>
@@ -5467,11 +5559,11 @@
           <a:p>
             <a:pPr>
               <a:spcAft>
-                <a:spcPts val="400"/>
-              </a:spcAft>
-            </a:pPr>
-            <a:r>
-              <a:rPr b="1" sz="1000">
+                <a:spcPts val="350"/>
+              </a:spcAft>
+            </a:pPr>
+            <a:r>
+              <a:rPr b="1" sz="950">
                 <a:solidFill>
                   <a:srgbClr val="2563EB"/>
                 </a:solidFill>
@@ -5479,22 +5571,22 @@
               <a:t>• React 18 &amp; Vite 8:</a:t>
             </a:r>
             <a:r>
-              <a:rPr sz="950">
+              <a:rPr sz="900">
                 <a:solidFill>
                   <a:srgbClr val="334155"/>
                 </a:solidFill>
               </a:rPr>
-              <a:t> Client-side component hierarchy, high-performance Virtual DOM updates, fast Hot Module Replacement, and optimized production chunking.</a:t>
-            </a:r>
-          </a:p>
-          <a:p>
-            <a:pPr>
-              <a:spcAft>
-                <a:spcPts val="400"/>
-              </a:spcAft>
-            </a:pPr>
-            <a:r>
-              <a:rPr b="1" sz="1000">
+              <a:t> Client-side component hierarchy, high-performance Virtual DOM updates, and fast Hot Module Replacement.</a:t>
+            </a:r>
+          </a:p>
+          <a:p>
+            <a:pPr>
+              <a:spcAft>
+                <a:spcPts val="350"/>
+              </a:spcAft>
+            </a:pPr>
+            <a:r>
+              <a:rPr b="1" sz="950">
                 <a:solidFill>
                   <a:srgbClr val="2563EB"/>
                 </a:solidFill>
@@ -5502,22 +5594,22 @@
               <a:t>• Tailwind CSS:</a:t>
             </a:r>
             <a:r>
-              <a:rPr sz="950">
+              <a:rPr sz="900">
                 <a:solidFill>
                   <a:srgbClr val="334155"/>
                 </a:solidFill>
               </a:rPr>
-              <a:t> Modern utility-first CSS framework enabling clean layout management, responsive grids, and frosted glassmorphic card effects.</a:t>
-            </a:r>
-          </a:p>
-          <a:p>
-            <a:pPr>
-              <a:spcAft>
-                <a:spcPts val="400"/>
-              </a:spcAft>
-            </a:pPr>
-            <a:r>
-              <a:rPr b="1" sz="1000">
+              <a:t> Modern utility-first CSS framework enabling clean layout management and frosted glassmorphic card effects.</a:t>
+            </a:r>
+          </a:p>
+          <a:p>
+            <a:pPr>
+              <a:spcAft>
+                <a:spcPts val="350"/>
+              </a:spcAft>
+            </a:pPr>
+            <a:r>
+              <a:rPr b="1" sz="950">
                 <a:solidFill>
                   <a:srgbClr val="2563EB"/>
                 </a:solidFill>
@@ -5525,22 +5617,22 @@
               <a:t>• Chart.js &amp; React-Chartjs-2:</a:t>
             </a:r>
             <a:r>
-              <a:rPr sz="950">
+              <a:rPr sz="900">
                 <a:solidFill>
                   <a:srgbClr val="334155"/>
                 </a:solidFill>
               </a:rPr>
-              <a:t> Rendered HTML5 canvas charts including radar skill benchmarks, 6-month attendance trajectory lines, and doughnut tier breakdowns.</a:t>
-            </a:r>
-          </a:p>
-          <a:p>
-            <a:pPr>
-              <a:spcAft>
-                <a:spcPts val="400"/>
-              </a:spcAft>
-            </a:pPr>
-            <a:r>
-              <a:rPr b="1" sz="1000">
+              <a:t> Rendered HTML5 canvas charts including radar skill benchmarks, 6-month attendance lines, and doughnuts.</a:t>
+            </a:r>
+          </a:p>
+          <a:p>
+            <a:pPr>
+              <a:spcAft>
+                <a:spcPts val="350"/>
+              </a:spcAft>
+            </a:pPr>
+            <a:r>
+              <a:rPr b="1" sz="950">
                 <a:solidFill>
                   <a:srgbClr val="2563EB"/>
                 </a:solidFill>
@@ -5548,22 +5640,22 @@
               <a:t>• Lucide React Icon Library:</a:t>
             </a:r>
             <a:r>
-              <a:rPr sz="950">
+              <a:rPr sz="900">
                 <a:solidFill>
                   <a:srgbClr val="334155"/>
                 </a:solidFill>
               </a:rPr>
-              <a:t> Over 25 clean, standardized enterprise icons providing visual clarity without using informal emojis.</a:t>
-            </a:r>
-          </a:p>
-          <a:p>
-            <a:pPr>
-              <a:spcAft>
-                <a:spcPts val="400"/>
-              </a:spcAft>
-            </a:pPr>
-            <a:r>
-              <a:rPr b="1" sz="1000">
+              <a:t> Over 30 standardized enterprise icons providing visual clarity without using informal emojis.</a:t>
+            </a:r>
+          </a:p>
+          <a:p>
+            <a:pPr>
+              <a:spcAft>
+                <a:spcPts val="350"/>
+              </a:spcAft>
+            </a:pPr>
+            <a:r>
+              <a:rPr b="1" sz="950">
                 <a:solidFill>
                   <a:srgbClr val="2563EB"/>
                 </a:solidFill>
@@ -5571,22 +5663,22 @@
               <a:t>• Node.js &amp; Express.js:</a:t>
             </a:r>
             <a:r>
-              <a:rPr sz="950">
+              <a:rPr sz="900">
                 <a:solidFill>
                   <a:srgbClr val="334155"/>
                 </a:solidFill>
               </a:rPr>
-              <a:t> Asynchronous runtime and RESTful API framework handling authentication, employee records, KPI math, and leave workflows.</a:t>
-            </a:r>
-          </a:p>
-          <a:p>
-            <a:pPr>
-              <a:spcAft>
-                <a:spcPts val="400"/>
-              </a:spcAft>
-            </a:pPr>
-            <a:r>
-              <a:rPr b="1" sz="1000">
+              <a:t> Asynchronous runtime and RESTful API framework handling authentication, records, and workflows.</a:t>
+            </a:r>
+          </a:p>
+          <a:p>
+            <a:pPr>
+              <a:spcAft>
+                <a:spcPts val="350"/>
+              </a:spcAft>
+            </a:pPr>
+            <a:r>
+              <a:rPr b="1" sz="950">
                 <a:solidFill>
                   <a:srgbClr val="2563EB"/>
                 </a:solidFill>
@@ -5594,7 +5686,7 @@
               <a:t>• MongoDB &amp; Mongoose ODM:</a:t>
             </a:r>
             <a:r>
-              <a:rPr sz="950">
+              <a:rPr sz="900">
                 <a:solidFill>
                   <a:srgbClr val="334155"/>
                 </a:solidFill>
@@ -5605,11 +5697,11 @@
           <a:p>
             <a:pPr>
               <a:spcAft>
-                <a:spcPts val="400"/>
-              </a:spcAft>
-            </a:pPr>
-            <a:r>
-              <a:rPr b="1" sz="1000">
+                <a:spcPts val="350"/>
+              </a:spcAft>
+            </a:pPr>
+            <a:r>
+              <a:rPr b="1" sz="950">
                 <a:solidFill>
                   <a:srgbClr val="2563EB"/>
                 </a:solidFill>
@@ -5617,7 +5709,7 @@
               <a:t>• JSON Web Tokens (JWT):</a:t>
             </a:r>
             <a:r>
-              <a:rPr sz="950">
+              <a:rPr sz="900">
                 <a:solidFill>
                   <a:srgbClr val="334155"/>
                 </a:solidFill>
@@ -5628,11 +5720,11 @@
           <a:p>
             <a:pPr>
               <a:spcAft>
-                <a:spcPts val="400"/>
-              </a:spcAft>
-            </a:pPr>
-            <a:r>
-              <a:rPr b="1" sz="1000">
+                <a:spcPts val="350"/>
+              </a:spcAft>
+            </a:pPr>
+            <a:r>
+              <a:rPr b="1" sz="950">
                 <a:solidFill>
                   <a:srgbClr val="2563EB"/>
                 </a:solidFill>
@@ -5640,12 +5732,12 @@
               <a:t>• Git &amp; GitHub:</a:t>
             </a:r>
             <a:r>
-              <a:rPr sz="950">
+              <a:rPr sz="900">
                 <a:solidFill>
                   <a:srgbClr val="334155"/>
                 </a:solidFill>
               </a:rPr>
-              <a:t> Version control repository with point-by-point commit history ([github.com/Shron03/HR-Hub](https://github.com/Shron03/HR-Hub)).</a:t>
+              <a:t> Version control repository maintaining point-by-point commit history ([github.com/Shron03/HR-Hub](https://github.com/Shron03/HR-Hub)).</a:t>
             </a:r>
           </a:p>
         </p:txBody>
@@ -5941,7 +6033,7 @@
               <a:spcAft>
                 <a:spcPts val="200"/>
               </a:spcAft>
-              <a:defRPr sz="1350" b="1">
+              <a:defRPr sz="1300" b="1">
                 <a:solidFill>
                   <a:srgbClr val="0F172A"/>
                 </a:solidFill>
@@ -5956,7 +6048,7 @@
               <a:spcAft>
                 <a:spcPts val="800"/>
               </a:spcAft>
-              <a:defRPr sz="1000">
+              <a:defRPr sz="950">
                 <a:solidFill>
                   <a:srgbClr val="64748B"/>
                 </a:solidFill>
@@ -5986,7 +6078,7 @@
                   <a:srgbClr val="334155"/>
                 </a:solidFill>
               </a:rPr>
-              <a:t> Mastered end-to-end coordination between client-side UI states, Express route controllers, and MongoDB document schemas.</a:t>
+              <a:t> Mastered end-to-end coordination between client-side UI states, Express route controllers, and MongoDB schemas.</a:t>
             </a:r>
           </a:p>
           <a:p>
@@ -6009,7 +6101,7 @@
                   <a:srgbClr val="334155"/>
                 </a:solidFill>
               </a:rPr>
-              <a:t> Implemented multi-tier user privilege separation across both frontend view routers and backend API endpoints.</a:t>
+              <a:t> Implemented multi-tier user privilege separation across both frontend views and backend API endpoints.</a:t>
             </a:r>
           </a:p>
           <a:p>
@@ -6032,7 +6124,7 @@
                   <a:srgbClr val="334155"/>
                 </a:solidFill>
               </a:rPr>
-              <a:t> Acquired deep knowledge in widescreen layout design, replacing vertical sidebars with sticky top headers for improved ergonomics.</a:t>
+              <a:t> Acquired deep knowledge in widescreen layout design, replacing vertical sidebars with sticky top headers.</a:t>
             </a:r>
           </a:p>
           <a:p>
@@ -6078,7 +6170,7 @@
                   <a:srgbClr val="334155"/>
                 </a:solidFill>
               </a:rPr>
-              <a:t> Designed and executed 5 automated test suites covering boundary math, concurrency stress tests, and authorization gates.</a:t>
+              <a:t> Designed and executed 6 automated test suites covering boundary math, concurrency, and authorization gates.</a:t>
             </a:r>
           </a:p>
           <a:p>
@@ -6101,7 +6193,7 @@
                   <a:srgbClr val="334155"/>
                 </a:solidFill>
               </a:rPr>
-              <a:t> Learned to craft uncluttered, accessible user interfaces following professional corporate design principles and zero-emoji mandates.</a:t>
+              <a:t> Crafted an uncluttered, accessible user interface following professional corporate design principles.</a:t>
             </a:r>
           </a:p>
         </p:txBody>
@@ -6177,7 +6269,7 @@
               <a:spcAft>
                 <a:spcPts val="200"/>
               </a:spcAft>
-              <a:defRPr sz="1350" b="1">
+              <a:defRPr sz="1300" b="1">
                 <a:solidFill>
                   <a:srgbClr val="0F172A"/>
                 </a:solidFill>
@@ -6192,7 +6284,7 @@
               <a:spcAft>
                 <a:spcPts val="800"/>
               </a:spcAft>
-              <a:defRPr sz="1000">
+              <a:defRPr sz="950">
                 <a:solidFill>
                   <a:srgbClr val="64748B"/>
                 </a:solidFill>

</xml_diff>